<commit_message>
go compare figure updates
</commit_message>
<xml_diff>
--- a/results/figures/GO_compare_edited.pptx
+++ b/results/figures/GO_compare_edited.pptx
@@ -314,7 +314,7 @@
           <a:p>
             <a:fld id="{E6744CE3-0875-4B69-89C0-6F72D8139561}" type="datetimeFigureOut">
               <a:rPr lang="en-GB" smtClean="0"/>
-              <a:t>19/12/2025</a:t>
+              <a:t>15/01/2026</a:t>
             </a:fld>
             <a:endParaRPr lang="en-GB"/>
           </a:p>
@@ -484,7 +484,7 @@
           <a:p>
             <a:fld id="{E6744CE3-0875-4B69-89C0-6F72D8139561}" type="datetimeFigureOut">
               <a:rPr lang="en-GB" smtClean="0"/>
-              <a:t>19/12/2025</a:t>
+              <a:t>15/01/2026</a:t>
             </a:fld>
             <a:endParaRPr lang="en-GB"/>
           </a:p>
@@ -730,7 +730,7 @@
           <a:p>
             <a:fld id="{E6744CE3-0875-4B69-89C0-6F72D8139561}" type="datetimeFigureOut">
               <a:rPr lang="en-GB" smtClean="0"/>
-              <a:t>19/12/2025</a:t>
+              <a:t>15/01/2026</a:t>
             </a:fld>
             <a:endParaRPr lang="en-GB"/>
           </a:p>
@@ -1018,7 +1018,7 @@
           <a:p>
             <a:fld id="{E6744CE3-0875-4B69-89C0-6F72D8139561}" type="datetimeFigureOut">
               <a:rPr lang="en-GB" smtClean="0"/>
-              <a:t>19/12/2025</a:t>
+              <a:t>15/01/2026</a:t>
             </a:fld>
             <a:endParaRPr lang="en-GB"/>
           </a:p>
@@ -1440,7 +1440,7 @@
           <a:p>
             <a:fld id="{E6744CE3-0875-4B69-89C0-6F72D8139561}" type="datetimeFigureOut">
               <a:rPr lang="en-GB" smtClean="0"/>
-              <a:t>19/12/2025</a:t>
+              <a:t>15/01/2026</a:t>
             </a:fld>
             <a:endParaRPr lang="en-GB"/>
           </a:p>
@@ -1558,7 +1558,7 @@
           <a:p>
             <a:fld id="{E6744CE3-0875-4B69-89C0-6F72D8139561}" type="datetimeFigureOut">
               <a:rPr lang="en-GB" smtClean="0"/>
-              <a:t>19/12/2025</a:t>
+              <a:t>15/01/2026</a:t>
             </a:fld>
             <a:endParaRPr lang="en-GB"/>
           </a:p>
@@ -1653,7 +1653,7 @@
           <a:p>
             <a:fld id="{E6744CE3-0875-4B69-89C0-6F72D8139561}" type="datetimeFigureOut">
               <a:rPr lang="en-GB" smtClean="0"/>
-              <a:t>19/12/2025</a:t>
+              <a:t>15/01/2026</a:t>
             </a:fld>
             <a:endParaRPr lang="en-GB"/>
           </a:p>
@@ -1866,7 +1866,7 @@
           <a:p>
             <a:fld id="{E6744CE3-0875-4B69-89C0-6F72D8139561}" type="datetimeFigureOut">
               <a:rPr lang="en-GB" smtClean="0"/>
-              <a:t>19/12/2025</a:t>
+              <a:t>15/01/2026</a:t>
             </a:fld>
             <a:endParaRPr lang="en-GB"/>
           </a:p>
@@ -12782,11 +12782,9 @@
           </a:custGeom>
           <a:ln w="38100" cap="flat">
             <a:solidFill>
-              <a:srgbClr val="1E90FF">
-                <a:alpha val="100000"/>
-              </a:srgbClr>
-            </a:solidFill>
-            <a:prstDash val="dash"/>
+              <a:srgbClr val="1E90FF"/>
+            </a:solidFill>
+            <a:prstDash val="solid"/>
             <a:round/>
           </a:ln>
         </p:spPr>
@@ -14037,6 +14035,17 @@
                 </a:solidFill>
               </a:rPr>
               <a:t> = -0.258</a:t>
+            </a:r>
+          </a:p>
+          <a:p>
+            <a:pPr algn="ctr"/>
+            <a:r>
+              <a:rPr lang="en-US" sz="1500" b="1" i="1" dirty="0">
+                <a:solidFill>
+                  <a:schemeClr val="bg1"/>
+                </a:solidFill>
+              </a:rPr>
+              <a:t>**</a:t>
             </a:r>
           </a:p>
         </p:txBody>

</xml_diff>